<commit_message>
feat: implement Adam optimizer from scratch in Word2Vec, update documentation, and slide deck
</commit_message>
<xml_diff>
--- a/machine_learning_fundamentals.pptx
+++ b/machine_learning_fundamentals.pptx
@@ -4410,7 +4410,7 @@
               </a:defRPr>
             </a:pPr>
             <a:r>
-              <a:t>Optimization: Adjusts embedding weights using SGD, forcing related terms (e.g. models/networks) to cluster together.</a:t>
+              <a:t>Optimization: Trained using the Adam optimizer implemented from scratch. Uses adaptive learning rates for faster, more stable coordinate updates.</a:t>
             </a:r>
           </a:p>
           <a:p>
@@ -6111,6 +6111,22 @@
             </a:pPr>
             <a:r>
               <a:t>Gradient Descent: Updates weights along negative gradient: w = w - eta * grad.</a:t>
+            </a:r>
+          </a:p>
+          <a:p>
+            <a:pPr>
+              <a:spcAft>
+                <a:spcPts val="800"/>
+              </a:spcAft>
+              <a:defRPr sz="1300">
+                <a:solidFill>
+                  <a:srgbClr val="A1A1AA"/>
+                </a:solidFill>
+                <a:latin typeface="Arial"/>
+              </a:defRPr>
+            </a:pPr>
+            <a:r>
+              <a:t>Adam Optimizer: Computes adaptive learning rates using first moment (momentum) and second moment (gradient variance). Scales updates per coordinate.</a:t>
             </a:r>
           </a:p>
           <a:p>

</xml_diff>